<commit_message>
feature_block formatting is done
</commit_message>
<xml_diff>
--- a/test_output.pptx
+++ b/test_output.pptx
@@ -938,7 +938,7 @@
                 </a:solidFill>
                 <a:latin typeface="Nimbus Roman"/>
               </a:rPr>
-              <a:t>Expansive backyard with distant views—ideal for outdoor play, dining, and relaxed.</a:t>
+              <a:t>Bright, open kitchen with clean cabinetry, recessed lighting, and easy flow into dining.</a:t>
             </a:r>
             <a:endParaRPr lang="en-CA" sz="1000" b="0" u="none" strike="noStrike">
               <a:solidFill>
@@ -994,7 +994,7 @@
                 </a:solidFill>
                 <a:latin typeface="Nimbus Roman"/>
               </a:rPr>
-              <a:t>Light-filled kitchen with modern finishes, generous counter space, and a smooth, functional.</a:t>
+              <a:t>Inviting living room with comfortable seating and a large window that fills the space.</a:t>
             </a:r>
             <a:endParaRPr lang="en-CA" sz="1000" b="0" u="none" strike="noStrike">
               <a:solidFill>
@@ -1050,7 +1050,7 @@
                 </a:solidFill>
                 <a:latin typeface="Nimbus Roman"/>
               </a:rPr>
-              <a:t>Spacious primary bedroom with plush upholstered headboard and tray-style lighting for.</a:t>
+              <a:t>Dining area with slider doors to the backyard, made for indoor-outdoor entertaining.</a:t>
             </a:r>
             <a:endParaRPr lang="en-CA" sz="1000" b="0" u="none" strike="noStrike">
               <a:solidFill>
@@ -1106,7 +1106,7 @@
                 </a:solidFill>
                 <a:latin typeface="Nimbus Roman"/>
               </a:rPr>
-              <a:t>Welcoming front exterior with a long driveway and a well-kept, attractive façade.</a:t>
+              <a:t>Welcoming street view with a well-kept exterior and standout curb appeal on Happyvale Ave.</a:t>
             </a:r>
             <a:endParaRPr lang="en-CA" sz="1000" b="0" u="none" strike="noStrike">
               <a:solidFill>
@@ -1162,7 +1162,7 @@
                 </a:solidFill>
                 <a:latin typeface="Nimbus Roman"/>
               </a:rPr>
-              <a:t>Bright living room with comfortable seating and a large window framing views outside.</a:t>
+              <a:t>Expansive backyard with neighboring views, perfect for relaxing, playing, and hosting.</a:t>
             </a:r>
             <a:endParaRPr lang="en-CA" sz="1000" b="0" u="none" strike="noStrike">
               <a:solidFill>
@@ -1276,7 +1276,7 @@
                 </a:solidFill>
                 <a:latin typeface="Nimbus Roman"/>
               </a:rPr>
-              <a:t>Enjoy over 1,700 sq. ft. in a bright, functional 3-level split townhome on desirable Happyvale Avenue.</a:t>
+              <a:t>Enjoy bright living across three levels in this 1,700+ sq ft townhome on desirable Happyvale Avenue.</a:t>
             </a:r>
             <a:endParaRPr lang="en-CA" sz="1100" b="0" u="none" strike="noStrike">
               <a:solidFill>
@@ -1309,7 +1309,7 @@
                 </a:solidFill>
                 <a:latin typeface="Nimbus Roman"/>
               </a:rPr>
-              <a:t>Cathedral entry and sunny dining flow to a sundeck, overlooking the fenced backyard and nearby green space.</a:t>
+              <a:t>Cathedral entry welcomes you into a spacious main floor with a sunny dining room and convenient laundry.</a:t>
             </a:r>
           </a:p>
           <a:p>
@@ -1334,7 +1334,7 @@
                 </a:solidFill>
                 <a:latin typeface="Nimbus Roman"/>
               </a:rPr>
-              <a:t>Renovated in 2012 with modern kitchen updates, refreshed flooring, appliances, windows, roof, plus upgraded decks and railings.</a:t>
+              <a:t>2012 renovations refreshed the kitchen, flooring, windows, roof, and modernized lighting, railings, and overall finishes.</a:t>
             </a:r>
           </a:p>
           <a:p>
@@ -1359,7 +1359,7 @@
                 </a:solidFill>
                 <a:latin typeface="Nimbus Roman"/>
               </a:rPr>
-              <a:t>Double attached garage with workshop space and four total parking spots provides effortless everyday convenience.</a:t>
+              <a:t>Park with ease using a double attached garage plus four total spaces, ideal for family and guests.</a:t>
             </a:r>
           </a:p>
           <a:p>
@@ -1384,7 +1384,7 @@
                 </a:solidFill>
                 <a:latin typeface="Nimbus Roman"/>
               </a:rPr>
-              <a:t>Pass-through access from the garage leads to the rear yard as the strata refreshes and paints siding.</a:t>
+              <a:t>Backs onto school-district land for a peaceful backdrop, with a sundeck and fenced yard for outdoor living.</a:t>
             </a:r>
           </a:p>
           <a:p>
@@ -1409,7 +1409,7 @@
                 </a:solidFill>
                 <a:latin typeface="Nimbus Roman"/>
               </a:rPr>
-              <a:t>Pet- and rental-friendly complex near schools, shopping, parks, and River’s Trail for a connected lifestyle.</a:t>
+              <a:t>Pet- and rental-friendly strata includes maintenance, insurance, and water for simple, worry-free ownership.</a:t>
             </a:r>
           </a:p>
         </p:txBody>
@@ -1491,7 +1491,7 @@
                 </a:solidFill>
                 <a:latin typeface="Nimbus Roman"/>
               </a:rPr>
-              <a:t>Happyvale Avenue Split-Level Living With Private Deck and Double Garage</a:t>
+              <a:t>Live Comfortably on Happyvale Ave With Space, Light, and a Private Yard</a:t>
             </a:r>
             <a:endParaRPr lang="en-CA" sz="1600" b="0" u="none" strike="noStrike">
               <a:solidFill>
@@ -1596,7 +1596,7 @@
       </p:sp>
       <p:pic>
         <p:nvPicPr>
-          <p:cNvPr id="28" name="Picture 27" descr="DSC03355.jpg"/>
+          <p:cNvPr id="28" name="Picture 27" descr="DSC03381.jpg"/>
           <p:cNvPicPr>
             <a:picLocks noChangeAspect="1"/>
           </p:cNvPicPr>
@@ -1621,7 +1621,7 @@
       </p:pic>
       <p:pic>
         <p:nvPicPr>
-          <p:cNvPr id="29" name="Picture 28" descr="DSC03381.jpg"/>
+          <p:cNvPr id="29" name="Picture 28" descr="DSC03369.jpg"/>
           <p:cNvPicPr>
             <a:picLocks noChangeAspect="1"/>
           </p:cNvPicPr>
@@ -1671,7 +1671,7 @@
       </p:pic>
       <p:pic>
         <p:nvPicPr>
-          <p:cNvPr id="31" name="Picture 30" descr="DSC03411.jpg"/>
+          <p:cNvPr id="31" name="Picture 30" descr="DSC03378.jpg"/>
           <p:cNvPicPr>
             <a:picLocks noChangeAspect="1"/>
           </p:cNvPicPr>
@@ -1679,7 +1679,7 @@
         </p:nvPicPr>
         <p:blipFill>
           <a:blip r:embed="rId6"/>
-          <a:srcRect l="6614" r="6614"/>
+          <a:srcRect l="6512" r="6512"/>
           <a:stretch>
             <a:fillRect/>
           </a:stretch>
@@ -1696,7 +1696,7 @@
       </p:pic>
       <p:pic>
         <p:nvPicPr>
-          <p:cNvPr id="32" name="Picture 31" descr="DSC03369.jpg"/>
+          <p:cNvPr id="32" name="Picture 31" descr="DSC03355.jpg"/>
           <p:cNvPicPr>
             <a:picLocks noChangeAspect="1"/>
           </p:cNvPicPr>
@@ -1721,7 +1721,7 @@
       </p:pic>
       <p:pic>
         <p:nvPicPr>
-          <p:cNvPr id="33" name="Picture 32" descr="DSC03343.jpg"/>
+          <p:cNvPr id="33" name="Picture 32" descr="DSC03341.jpg"/>
           <p:cNvPicPr>
             <a:picLocks noChangeAspect="1"/>
           </p:cNvPicPr>
@@ -1814,7 +1814,7 @@
                 </a:solidFill>
                 <a:latin typeface="Nimbus Roman"/>
               </a:rPr>
-              <a:t>Dining area overlooks lush greenery, creating a sunny everyday space for meals and.</a:t>
+              <a:t>Primary bedroom with a striking upholstered headboard and plenty of natural light.</a:t>
             </a:r>
             <a:endParaRPr lang="en-CA" sz="1000" b="0" u="none" strike="noStrike">
               <a:solidFill>
@@ -1870,7 +1870,7 @@
                 </a:solidFill>
                 <a:latin typeface="Nimbus Roman"/>
               </a:rPr>
-              <a:t>Private deck for outdoor dining and grilling—an easy extension of daily living.</a:t>
+              <a:t>Unwind on the deck while enjoying backyard views, with a built-in grill area.</a:t>
             </a:r>
             <a:endParaRPr lang="en-CA" sz="1000" b="0" u="none" strike="noStrike">
               <a:solidFill>
@@ -1926,7 +1926,7 @@
                 </a:solidFill>
                 <a:latin typeface="Nimbus Roman"/>
               </a:rPr>
-              <a:t>Clean, bright full bath with updated fixtures and a granite-style vanity plus shower/tub.</a:t>
+              <a:t>Clean, bright bathroom with a dual-sink vanity and a full shower/tub surround.</a:t>
             </a:r>
             <a:endParaRPr lang="en-CA" sz="1000" b="0" u="none" strike="noStrike">
               <a:solidFill>
@@ -1982,7 +1982,7 @@
                 </a:solidFill>
                 <a:latin typeface="Nimbus Roman"/>
               </a:rPr>
-              <a:t>Wide driveway and side approach for easy parking, with a clear view toward the garage.</a:t>
+              <a:t>Attractive vanity bathroom with dual mirrors and a tidy, modern countertop finish.</a:t>
             </a:r>
             <a:endParaRPr lang="en-CA" sz="1000" b="0" u="none" strike="noStrike">
               <a:solidFill>
@@ -2038,7 +2038,7 @@
                 </a:solidFill>
                 <a:latin typeface="Nimbus Roman"/>
               </a:rPr>
-              <a:t>Spacious bedroom with fresh paint, ample closet space, and a convenient hallway flow.</a:t>
+              <a:t>Primary bedroom with calm neutral finishes, a comfortable layout, and great everyday.</a:t>
             </a:r>
             <a:endParaRPr lang="en-CA" sz="1000" b="0" u="none" strike="noStrike">
               <a:solidFill>
@@ -2317,6 +2317,34 @@
                 </a:solidFill>
                 <a:latin typeface="Nimbus Roman"/>
               </a:rPr>
+              <a:t>Fireplace:	Year Subst Reno2012Prop Condition</a:t>
+            </a:r>
+          </a:p>
+          <a:p>
+            <a:pPr>
+              <a:lnSpc>
+                <a:spcPct val="100000"/>
+              </a:lnSpc>
+              <a:spcBef>
+                <a:spcPts val="2100"/>
+              </a:spcBef>
+              <a:spcAft>
+                <a:spcPts val="0"/>
+              </a:spcAft>
+              <a:tabLst>
+                <a:tab algn="l" pos="0"/>
+                <a:tab algn="l" pos="347040"/>
+                <a:tab algn="l" pos="898200"/>
+                <a:tab algn="l" pos="4027680"/>
+              </a:tabLst>
+            </a:pPr>
+            <a:r>
+              <a:rPr b="1" sz="1400">
+                <a:solidFill>
+                  <a:srgbClr val="000000"/>
+                </a:solidFill>
+                <a:latin typeface="Nimbus Roman"/>
+              </a:rPr>
               <a:t>Includes:	Dishwasher</a:t>
             </a:r>
           </a:p>
@@ -2466,6 +2494,62 @@
                 <a:spcPct val="100000"/>
               </a:lnSpc>
               <a:spcBef>
+                <a:spcPts val="700"/>
+              </a:spcBef>
+              <a:spcAft>
+                <a:spcPts val="0"/>
+              </a:spcAft>
+              <a:tabLst>
+                <a:tab algn="l" pos="0"/>
+                <a:tab algn="l" pos="347040"/>
+                <a:tab algn="l" pos="898200"/>
+                <a:tab algn="l" pos="4027680"/>
+              </a:tabLst>
+            </a:pPr>
+            <a:r>
+              <a:rPr b="1" sz="1400">
+                <a:solidFill>
+                  <a:srgbClr val="000000"/>
+                </a:solidFill>
+                <a:latin typeface="Nimbus Roman"/>
+              </a:rPr>
+              <a:t>		Pet Friendly</a:t>
+            </a:r>
+          </a:p>
+          <a:p>
+            <a:pPr>
+              <a:lnSpc>
+                <a:spcPct val="100000"/>
+              </a:lnSpc>
+              <a:spcBef>
+                <a:spcPts val="700"/>
+              </a:spcBef>
+              <a:spcAft>
+                <a:spcPts val="0"/>
+              </a:spcAft>
+              <a:tabLst>
+                <a:tab algn="l" pos="0"/>
+                <a:tab algn="l" pos="347040"/>
+                <a:tab algn="l" pos="898200"/>
+                <a:tab algn="l" pos="4027680"/>
+              </a:tabLst>
+            </a:pPr>
+            <a:r>
+              <a:rPr b="1" sz="1400">
+                <a:solidFill>
+                  <a:srgbClr val="000000"/>
+                </a:solidFill>
+                <a:latin typeface="Nimbus Roman"/>
+              </a:rPr>
+              <a:t>		Rental Friendly</a:t>
+            </a:r>
+          </a:p>
+          <a:p>
+            <a:pPr>
+              <a:lnSpc>
+                <a:spcPct val="100000"/>
+              </a:lnSpc>
+              <a:spcBef>
                 <a:spcPts val="2100"/>
               </a:spcBef>
               <a:spcAft>
@@ -2529,7 +2613,7 @@
                 </a:solidFill>
                 <a:latin typeface="Nimbus Roman"/>
               </a:rPr>
-              <a:t>Basement (674.9 sq. ft.)</a:t>
+              <a:t>Home (1,721 sq. ft.)</a:t>
             </a:r>
             <a:endParaRPr lang="en-CA" sz="1400" b="0" u="none" strike="noStrike">
               <a:solidFill>
@@ -2557,7 +2641,7 @@
                 </a:solidFill>
                 <a:latin typeface="Nimbus Roman"/>
               </a:rPr>
-              <a:t>Bedroom	12' 7" x 12' 9"</a:t>
+              <a:t>Kitchen	10' 4" x 13' 11"</a:t>
             </a:r>
           </a:p>
           <a:p>
@@ -2576,7 +2660,7 @@
                 </a:solidFill>
                 <a:latin typeface="Nimbus Roman"/>
               </a:rPr>
-              <a:t>Family Room	19' 3" x 12' 6"</a:t>
+              <a:t>Living Room	14' 4" x 14' 9"</a:t>
             </a:r>
           </a:p>
           <a:p>
@@ -2595,29 +2679,9 @@
                 </a:solidFill>
                 <a:latin typeface="Nimbus Roman"/>
               </a:rPr>
-              <a:t>Storage	18' 9" x 6' </a:t>
-            </a:r>
-          </a:p>
-          <a:p>
-            <a:pPr algn="ctr">
-              <a:lnSpc>
-                <a:spcPct val="150000"/>
-              </a:lnSpc>
-              <a:tabLst>
-                <a:tab algn="l" pos="1619280"/>
-              </a:tabLst>
-            </a:pPr>
-            <a:r>
-              <a:rPr b="1" sz="1400" i="1">
-                <a:solidFill>
-                  <a:srgbClr val="000000"/>
-                </a:solidFill>
-                <a:latin typeface="Nimbus Roman"/>
-              </a:rPr>
-              <a:t>Main (1,046 sq. ft.)</a:t>
-            </a:r>
-          </a:p>
-          <a:p/>
+              <a:t>Dining Room	9' 2" x 8' 9"</a:t>
+            </a:r>
+          </a:p>
           <a:p>
             <a:pPr>
               <a:lnSpc>
@@ -2634,7 +2698,7 @@
                 </a:solidFill>
                 <a:latin typeface="Nimbus Roman"/>
               </a:rPr>
-              <a:t>Kitchen	10' 4" x 13' 11"</a:t>
+              <a:t>Primary Bedroom	11' 8" x 10' 6"</a:t>
             </a:r>
           </a:p>
           <a:p>
@@ -2653,7 +2717,7 @@
                 </a:solidFill>
                 <a:latin typeface="Nimbus Roman"/>
               </a:rPr>
-              <a:t>Living Room	14' 4" x 14' 9"</a:t>
+              <a:t>Bedroom	8' 3" x 8' 9"</a:t>
             </a:r>
           </a:p>
           <a:p>
@@ -2672,7 +2736,7 @@
                 </a:solidFill>
                 <a:latin typeface="Nimbus Roman"/>
               </a:rPr>
-              <a:t>Dining Room	9' 2" x 8' 9"</a:t>
+              <a:t>Bedroom	12' 7" x 12' 9" 8' 9" x 9' 9"</a:t>
             </a:r>
           </a:p>
           <a:p>
@@ -2691,7 +2755,7 @@
                 </a:solidFill>
                 <a:latin typeface="Nimbus Roman"/>
               </a:rPr>
-              <a:t>Primary Bedroom	11' 8" x 10' 6"</a:t>
+              <a:t>Bathroom - Full	4 PCE</a:t>
             </a:r>
           </a:p>
           <a:p>
@@ -2710,7 +2774,7 @@
                 </a:solidFill>
                 <a:latin typeface="Nimbus Roman"/>
               </a:rPr>
-              <a:t>Bedroom	8' 3" x 8' 9"</a:t>
+              <a:t>Ensuite - Half	2 PCE</a:t>
             </a:r>
           </a:p>
           <a:p>
@@ -2729,7 +2793,7 @@
                 </a:solidFill>
                 <a:latin typeface="Nimbus Roman"/>
               </a:rPr>
-              <a:t>Bathroom - Full	4 PCE</a:t>
+              <a:t>Laundry	9' 3" x 3' </a:t>
             </a:r>
           </a:p>
           <a:p>
@@ -2748,7 +2812,7 @@
                 </a:solidFill>
                 <a:latin typeface="Nimbus Roman"/>
               </a:rPr>
-              <a:t>Ensuite - Half	2 PCE</a:t>
+              <a:t>Family Room	19' 3" x 12' 6"</a:t>
             </a:r>
           </a:p>
           <a:p>
@@ -2767,7 +2831,7 @@
                 </a:solidFill>
                 <a:latin typeface="Nimbus Roman"/>
               </a:rPr>
-              <a:t>Laundry	9' 3" x 3' </a:t>
+              <a:t>Storage	18' 9" x 6' </a:t>
             </a:r>
           </a:p>
         </p:txBody>
@@ -2819,7 +2883,7 @@
       </p:sp>
       <p:pic>
         <p:nvPicPr>
-          <p:cNvPr id="43" name="Picture 42" descr="DSC03378.jpg"/>
+          <p:cNvPr id="43" name="Picture 42" descr="DSC03411.jpg"/>
           <p:cNvPicPr>
             <a:picLocks noChangeAspect="1"/>
           </p:cNvPicPr>
@@ -2827,7 +2891,7 @@
         </p:nvPicPr>
         <p:blipFill>
           <a:blip r:embed="rId3"/>
-          <a:srcRect l="6818" r="6818"/>
+          <a:srcRect l="6919" r="6919"/>
           <a:stretch>
             <a:fillRect/>
           </a:stretch>
@@ -2894,7 +2958,7 @@
       </p:pic>
       <p:pic>
         <p:nvPicPr>
-          <p:cNvPr id="46" name="Picture 45" descr="DSC03423.jpg"/>
+          <p:cNvPr id="46" name="Picture 45" descr="DSC03434.jpg"/>
           <p:cNvPicPr>
             <a:picLocks noChangeAspect="1"/>
           </p:cNvPicPr>
@@ -2902,7 +2966,7 @@
         </p:nvPicPr>
         <p:blipFill>
           <a:blip r:embed="rId6"/>
-          <a:srcRect l="13715" r="13715"/>
+          <a:srcRect l="13800" r="13800"/>
           <a:stretch>
             <a:fillRect/>
           </a:stretch>
@@ -2919,7 +2983,7 @@
       </p:pic>
       <p:pic>
         <p:nvPicPr>
-          <p:cNvPr id="47" name="Picture 46" descr="DSC03439.jpg"/>
+          <p:cNvPr id="47" name="Picture 46" descr="DSC03417.jpg"/>
           <p:cNvPicPr>
             <a:picLocks noChangeAspect="1"/>
           </p:cNvPicPr>
@@ -2927,7 +2991,7 @@
         </p:nvPicPr>
         <p:blipFill>
           <a:blip r:embed="rId7"/>
-          <a:srcRect l="6816" r="6816"/>
+          <a:srcRect l="6917" r="6917"/>
           <a:stretch>
             <a:fillRect/>
           </a:stretch>

</xml_diff>

<commit_message>
updated to gpt-5.4, everything works much better now
</commit_message>
<xml_diff>
--- a/test_output.pptx
+++ b/test_output.pptx
@@ -938,7 +938,7 @@
                 </a:solidFill>
                 <a:latin typeface="Nimbus Roman"/>
               </a:rPr>
-              <a:t>Bright, open kitchen with clean cabinetry, recessed lighting, and easy flow into dining.</a:t>
+              <a:t>Open green outlook with mountain views, adding a peaceful backdrop to everyday living.</a:t>
             </a:r>
             <a:endParaRPr lang="en-CA" sz="1000" b="0" u="none" strike="noStrike">
               <a:solidFill>
@@ -994,7 +994,7 @@
                 </a:solidFill>
                 <a:latin typeface="Nimbus Roman"/>
               </a:rPr>
-              <a:t>Inviting living room with comfortable seating and a large window that fills the space.</a:t>
+              <a:t>Dining area connects seamlessly to the kitchen and opens directly onto the sunny deck.</a:t>
             </a:r>
             <a:endParaRPr lang="en-CA" sz="1000" b="0" u="none" strike="noStrike">
               <a:solidFill>
@@ -1050,7 +1050,7 @@
                 </a:solidFill>
                 <a:latin typeface="Nimbus Roman"/>
               </a:rPr>
-              <a:t>Dining area with slider doors to the backyard, made for indoor-outdoor entertaining.</a:t>
+              <a:t>Bright kitchen with peninsula seating, ample prep space, and leafy views from the window.</a:t>
             </a:r>
             <a:endParaRPr lang="en-CA" sz="1000" b="0" u="none" strike="noStrike">
               <a:solidFill>
@@ -1106,7 +1106,7 @@
                 </a:solidFill>
                 <a:latin typeface="Nimbus Roman"/>
               </a:rPr>
-              <a:t>Welcoming street view with a well-kept exterior and standout curb appeal on Happyvale Ave.</a:t>
+              <a:t>Fenced backyard with mature shade, open lawn, and a pleasant green outlook beyond.</a:t>
             </a:r>
             <a:endParaRPr lang="en-CA" sz="1000" b="0" u="none" strike="noStrike">
               <a:solidFill>
@@ -1162,7 +1162,7 @@
                 </a:solidFill>
                 <a:latin typeface="Nimbus Roman"/>
               </a:rPr>
-              <a:t>Expansive backyard with neighboring views, perfect for relaxing, playing, and hosting.</a:t>
+              <a:t>Welcoming living room filled with natural light from the large front-facing window.</a:t>
             </a:r>
             <a:endParaRPr lang="en-CA" sz="1000" b="0" u="none" strike="noStrike">
               <a:solidFill>
@@ -1276,7 +1276,7 @@
                 </a:solidFill>
                 <a:latin typeface="Nimbus Roman"/>
               </a:rPr>
-              <a:t>Enjoy bright living across three levels in this 1,700+ sq ft townhome on desirable Happyvale Avenue.</a:t>
+              <a:t>Bright and functional cathedral-entry townhome offering over 1,700 sq. ft. across a flexible three-level split design.</a:t>
             </a:r>
             <a:endParaRPr lang="en-CA" sz="1100" b="0" u="none" strike="noStrike">
               <a:solidFill>
@@ -1309,7 +1309,7 @@
                 </a:solidFill>
                 <a:latin typeface="Nimbus Roman"/>
               </a:rPr>
-              <a:t>Cathedral entry welcomes you into a spacious main floor with a sunny dining room and convenient laundry.</a:t>
+              <a:t>Thoughtfully renovated in 2012 with updates to the kitchen, flooring, appliances, windows, roof, lighting, decks, and railings.</a:t>
             </a:r>
           </a:p>
           <a:p>
@@ -1334,7 +1334,7 @@
                 </a:solidFill>
                 <a:latin typeface="Nimbus Roman"/>
               </a:rPr>
-              <a:t>2012 renovations refreshed the kitchen, flooring, windows, roof, and modernized lighting, railings, and overall finishes.</a:t>
+              <a:t>The sunny dining area opens to a sundeck overlooking the fenced yard and peaceful green space beyond.</a:t>
             </a:r>
           </a:p>
           <a:p>
@@ -1359,7 +1359,7 @@
                 </a:solidFill>
                 <a:latin typeface="Nimbus Roman"/>
               </a:rPr>
-              <a:t>Park with ease using a double attached garage plus four total spaces, ideal for family and guests.</a:t>
+              <a:t>A versatile layout includes main floor laundry, a spacious family room, and a lower-level bedroom ideal for guests or a home office.</a:t>
             </a:r>
           </a:p>
           <a:p>
@@ -1384,7 +1384,7 @@
                 </a:solidFill>
                 <a:latin typeface="Nimbus Roman"/>
               </a:rPr>
-              <a:t>Backs onto school-district land for a peaceful backdrop, with a sundeck and fenced yard for outdoor living.</a:t>
+              <a:t>The double attached garage provides workshop potential and rear yard access, complemented by driveway parking and an assigned stall.</a:t>
             </a:r>
           </a:p>
           <a:p>
@@ -1409,7 +1409,7 @@
                 </a:solidFill>
                 <a:latin typeface="Nimbus Roman"/>
               </a:rPr>
-              <a:t>Pet- and rental-friendly strata includes maintenance, insurance, and water for simple, worry-free ownership.</a:t>
+              <a:t>Pet- and rental-friendly in Brocklehurst, close to schools, shopping, McArthur Island Park, and the scenic River’s Trail.</a:t>
             </a:r>
           </a:p>
         </p:txBody>
@@ -1491,7 +1491,7 @@
                 </a:solidFill>
                 <a:latin typeface="Nimbus Roman"/>
               </a:rPr>
-              <a:t>Live Comfortably on Happyvale Ave With Space, Light, and a Private Yard</a:t>
+              <a:t>Bright Brocklehurst Townhome With Greenbelt Views And Room To Grow</a:t>
             </a:r>
             <a:endParaRPr lang="en-CA" sz="1600" b="0" u="none" strike="noStrike">
               <a:solidFill>
@@ -1536,7 +1536,7 @@
                 </a:solidFill>
                 <a:latin typeface="Nimbus Roman"/>
               </a:rPr>
-              <a:t>$499,900.00</a:t>
+              <a:t>$499,900</a:t>
             </a:r>
             <a:endParaRPr lang="en-CA" sz="2000" b="0" u="none" strike="noStrike">
               <a:solidFill>
@@ -1596,7 +1596,7 @@
       </p:sp>
       <p:pic>
         <p:nvPicPr>
-          <p:cNvPr id="28" name="Picture 27" descr="DSC03381.jpg"/>
+          <p:cNvPr id="28" name="Picture 27" descr="DSC03355.jpg"/>
           <p:cNvPicPr>
             <a:picLocks noChangeAspect="1"/>
           </p:cNvPicPr>
@@ -1621,7 +1621,7 @@
       </p:pic>
       <p:pic>
         <p:nvPicPr>
-          <p:cNvPr id="29" name="Picture 28" descr="DSC03369.jpg"/>
+          <p:cNvPr id="29" name="Picture 28" descr="DSC03378.jpg"/>
           <p:cNvPicPr>
             <a:picLocks noChangeAspect="1"/>
           </p:cNvPicPr>
@@ -1646,7 +1646,7 @@
       </p:pic>
       <p:pic>
         <p:nvPicPr>
-          <p:cNvPr id="30" name="Picture 29" descr="DSC03442.jpg"/>
+          <p:cNvPr id="30" name="Picture 29" descr="DSC03349.jpg"/>
           <p:cNvPicPr>
             <a:picLocks noChangeAspect="1"/>
           </p:cNvPicPr>
@@ -1671,7 +1671,7 @@
       </p:pic>
       <p:pic>
         <p:nvPicPr>
-          <p:cNvPr id="31" name="Picture 30" descr="DSC03378.jpg"/>
+          <p:cNvPr id="31" name="Picture 30" descr="DSC03381.jpg"/>
           <p:cNvPicPr>
             <a:picLocks noChangeAspect="1"/>
           </p:cNvPicPr>
@@ -1696,7 +1696,7 @@
       </p:pic>
       <p:pic>
         <p:nvPicPr>
-          <p:cNvPr id="32" name="Picture 31" descr="DSC03355.jpg"/>
+          <p:cNvPr id="32" name="Picture 31" descr="DSC03372.jpg"/>
           <p:cNvPicPr>
             <a:picLocks noChangeAspect="1"/>
           </p:cNvPicPr>
@@ -1704,7 +1704,7 @@
         </p:nvPicPr>
         <p:blipFill>
           <a:blip r:embed="rId7"/>
-          <a:srcRect l="7442" r="7442"/>
+          <a:srcRect l="7541" r="7541"/>
           <a:stretch>
             <a:fillRect/>
           </a:stretch>
@@ -1721,7 +1721,7 @@
       </p:pic>
       <p:pic>
         <p:nvPicPr>
-          <p:cNvPr id="33" name="Picture 32" descr="DSC03341.jpg"/>
+          <p:cNvPr id="33" name="Picture 32" descr="DSC03343.jpg"/>
           <p:cNvPicPr>
             <a:picLocks noChangeAspect="1"/>
           </p:cNvPicPr>
@@ -1814,7 +1814,7 @@
                 </a:solidFill>
                 <a:latin typeface="Nimbus Roman"/>
               </a:rPr>
-              <a:t>Primary bedroom with a striking upholstered headboard and plenty of natural light.</a:t>
+              <a:t>Covered deck with room for grilling, dining, and enjoying the private backyard setting.</a:t>
             </a:r>
             <a:endParaRPr lang="en-CA" sz="1000" b="0" u="none" strike="noStrike">
               <a:solidFill>
@@ -1870,7 +1870,7 @@
                 </a:solidFill>
                 <a:latin typeface="Nimbus Roman"/>
               </a:rPr>
-              <a:t>Unwind on the deck while enjoying backyard views, with a built-in grill area.</a:t>
+              <a:t>Spacious primary bedroom featuring soft carpet, natural light, and a stylish accent wall.</a:t>
             </a:r>
             <a:endParaRPr lang="en-CA" sz="1000" b="0" u="none" strike="noStrike">
               <a:solidFill>
@@ -1926,7 +1926,7 @@
                 </a:solidFill>
                 <a:latin typeface="Nimbus Roman"/>
               </a:rPr>
-              <a:t>Clean, bright bathroom with a dual-sink vanity and a full shower/tub surround.</a:t>
+              <a:t>Flexible lower-level rec room suited to media, workouts, hobbies, or work-from-home needs.</a:t>
             </a:r>
             <a:endParaRPr lang="en-CA" sz="1000" b="0" u="none" strike="noStrike">
               <a:solidFill>
@@ -1982,7 +1982,7 @@
                 </a:solidFill>
                 <a:latin typeface="Nimbus Roman"/>
               </a:rPr>
-              <a:t>Attractive vanity bathroom with dual mirrors and a tidy, modern countertop finish.</a:t>
+              <a:t>Versatile bedroom works equally well for guests, a nursery, or a bright home office.</a:t>
             </a:r>
             <a:endParaRPr lang="en-CA" sz="1000" b="0" u="none" strike="noStrike">
               <a:solidFill>
@@ -2038,7 +2038,7 @@
                 </a:solidFill>
                 <a:latin typeface="Nimbus Roman"/>
               </a:rPr>
-              <a:t>Primary bedroom with calm neutral finishes, a comfortable layout, and great everyday.</a:t>
+              <a:t>Clean, bright full bathroom with natural light and a practical everyday layout.</a:t>
             </a:r>
             <a:endParaRPr lang="en-CA" sz="1000" b="0" u="none" strike="noStrike">
               <a:solidFill>
@@ -2317,7 +2317,203 @@
                 </a:solidFill>
                 <a:latin typeface="Nimbus Roman"/>
               </a:rPr>
-              <a:t>Fireplace:	Year Subst Reno2012Prop Condition</a:t>
+              <a:t>Includes:	Dishwasher</a:t>
+            </a:r>
+          </a:p>
+          <a:p>
+            <a:pPr>
+              <a:lnSpc>
+                <a:spcPct val="100000"/>
+              </a:lnSpc>
+              <a:spcBef>
+                <a:spcPts val="700"/>
+              </a:spcBef>
+              <a:spcAft>
+                <a:spcPts val="0"/>
+              </a:spcAft>
+              <a:tabLst>
+                <a:tab algn="l" pos="0"/>
+                <a:tab algn="l" pos="347040"/>
+                <a:tab algn="l" pos="898200"/>
+                <a:tab algn="l" pos="4027680"/>
+              </a:tabLst>
+            </a:pPr>
+            <a:r>
+              <a:rPr b="1" sz="1400">
+                <a:solidFill>
+                  <a:srgbClr val="000000"/>
+                </a:solidFill>
+                <a:latin typeface="Nimbus Roman"/>
+              </a:rPr>
+              <a:t>		Electric Range</a:t>
+            </a:r>
+          </a:p>
+          <a:p>
+            <a:pPr>
+              <a:lnSpc>
+                <a:spcPct val="100000"/>
+              </a:lnSpc>
+              <a:spcBef>
+                <a:spcPts val="700"/>
+              </a:spcBef>
+              <a:spcAft>
+                <a:spcPts val="0"/>
+              </a:spcAft>
+              <a:tabLst>
+                <a:tab algn="l" pos="0"/>
+                <a:tab algn="l" pos="347040"/>
+                <a:tab algn="l" pos="898200"/>
+                <a:tab algn="l" pos="4027680"/>
+              </a:tabLst>
+            </a:pPr>
+            <a:r>
+              <a:rPr b="1" sz="1400">
+                <a:solidFill>
+                  <a:srgbClr val="000000"/>
+                </a:solidFill>
+                <a:latin typeface="Nimbus Roman"/>
+              </a:rPr>
+              <a:t>		Refrigerator</a:t>
+            </a:r>
+          </a:p>
+          <a:p>
+            <a:pPr>
+              <a:lnSpc>
+                <a:spcPct val="100000"/>
+              </a:lnSpc>
+              <a:spcBef>
+                <a:spcPts val="700"/>
+              </a:spcBef>
+              <a:spcAft>
+                <a:spcPts val="0"/>
+              </a:spcAft>
+              <a:tabLst>
+                <a:tab algn="l" pos="0"/>
+                <a:tab algn="l" pos="347040"/>
+                <a:tab algn="l" pos="898200"/>
+                <a:tab algn="l" pos="4027680"/>
+              </a:tabLst>
+            </a:pPr>
+            <a:r>
+              <a:rPr b="1" sz="1400">
+                <a:solidFill>
+                  <a:srgbClr val="000000"/>
+                </a:solidFill>
+                <a:latin typeface="Nimbus Roman"/>
+              </a:rPr>
+              <a:t>		Washer/Dryer</a:t>
+            </a:r>
+          </a:p>
+          <a:p>
+            <a:pPr>
+              <a:lnSpc>
+                <a:spcPct val="100000"/>
+              </a:lnSpc>
+              <a:spcBef>
+                <a:spcPts val="700"/>
+              </a:spcBef>
+              <a:spcAft>
+                <a:spcPts val="0"/>
+              </a:spcAft>
+              <a:tabLst>
+                <a:tab algn="l" pos="0"/>
+                <a:tab algn="l" pos="347040"/>
+                <a:tab algn="l" pos="898200"/>
+                <a:tab algn="l" pos="4027680"/>
+              </a:tabLst>
+            </a:pPr>
+            <a:r>
+              <a:rPr b="1" sz="1400">
+                <a:solidFill>
+                  <a:srgbClr val="000000"/>
+                </a:solidFill>
+                <a:latin typeface="Nimbus Roman"/>
+              </a:rPr>
+              <a:t>		Deck</a:t>
+            </a:r>
+          </a:p>
+          <a:p>
+            <a:pPr>
+              <a:lnSpc>
+                <a:spcPct val="100000"/>
+              </a:lnSpc>
+              <a:spcBef>
+                <a:spcPts val="700"/>
+              </a:spcBef>
+              <a:spcAft>
+                <a:spcPts val="0"/>
+              </a:spcAft>
+              <a:tabLst>
+                <a:tab algn="l" pos="0"/>
+                <a:tab algn="l" pos="347040"/>
+                <a:tab algn="l" pos="898200"/>
+                <a:tab algn="l" pos="4027680"/>
+              </a:tabLst>
+            </a:pPr>
+            <a:r>
+              <a:rPr b="1" sz="1400">
+                <a:solidFill>
+                  <a:srgbClr val="000000"/>
+                </a:solidFill>
+                <a:latin typeface="Nimbus Roman"/>
+              </a:rPr>
+              <a:t>		Private Yard</a:t>
+            </a:r>
+          </a:p>
+          <a:p>
+            <a:pPr>
+              <a:lnSpc>
+                <a:spcPct val="100000"/>
+              </a:lnSpc>
+              <a:spcBef>
+                <a:spcPts val="700"/>
+              </a:spcBef>
+              <a:spcAft>
+                <a:spcPts val="0"/>
+              </a:spcAft>
+              <a:tabLst>
+                <a:tab algn="l" pos="0"/>
+                <a:tab algn="l" pos="347040"/>
+                <a:tab algn="l" pos="898200"/>
+                <a:tab algn="l" pos="4027680"/>
+              </a:tabLst>
+            </a:pPr>
+            <a:r>
+              <a:rPr b="1" sz="1400">
+                <a:solidFill>
+                  <a:srgbClr val="000000"/>
+                </a:solidFill>
+                <a:latin typeface="Nimbus Roman"/>
+              </a:rPr>
+              <a:t>		Pet Friendly</a:t>
+            </a:r>
+          </a:p>
+          <a:p>
+            <a:pPr>
+              <a:lnSpc>
+                <a:spcPct val="100000"/>
+              </a:lnSpc>
+              <a:spcBef>
+                <a:spcPts val="700"/>
+              </a:spcBef>
+              <a:spcAft>
+                <a:spcPts val="0"/>
+              </a:spcAft>
+              <a:tabLst>
+                <a:tab algn="l" pos="0"/>
+                <a:tab algn="l" pos="347040"/>
+                <a:tab algn="l" pos="898200"/>
+                <a:tab algn="l" pos="4027680"/>
+              </a:tabLst>
+            </a:pPr>
+            <a:r>
+              <a:rPr b="1" sz="1400">
+                <a:solidFill>
+                  <a:srgbClr val="000000"/>
+                </a:solidFill>
+                <a:latin typeface="Nimbus Roman"/>
+              </a:rPr>
+              <a:t>		Rental Friendly</a:t>
             </a:r>
           </a:p>
           <a:p>
@@ -2345,203 +2541,7 @@
                 </a:solidFill>
                 <a:latin typeface="Nimbus Roman"/>
               </a:rPr>
-              <a:t>Includes:	Dishwasher</a:t>
-            </a:r>
-          </a:p>
-          <a:p>
-            <a:pPr>
-              <a:lnSpc>
-                <a:spcPct val="100000"/>
-              </a:lnSpc>
-              <a:spcBef>
-                <a:spcPts val="700"/>
-              </a:spcBef>
-              <a:spcAft>
-                <a:spcPts val="0"/>
-              </a:spcAft>
-              <a:tabLst>
-                <a:tab algn="l" pos="0"/>
-                <a:tab algn="l" pos="347040"/>
-                <a:tab algn="l" pos="898200"/>
-                <a:tab algn="l" pos="4027680"/>
-              </a:tabLst>
-            </a:pPr>
-            <a:r>
-              <a:rPr b="1" sz="1400">
-                <a:solidFill>
-                  <a:srgbClr val="000000"/>
-                </a:solidFill>
-                <a:latin typeface="Nimbus Roman"/>
-              </a:rPr>
-              <a:t>		Electric Range</a:t>
-            </a:r>
-          </a:p>
-          <a:p>
-            <a:pPr>
-              <a:lnSpc>
-                <a:spcPct val="100000"/>
-              </a:lnSpc>
-              <a:spcBef>
-                <a:spcPts val="700"/>
-              </a:spcBef>
-              <a:spcAft>
-                <a:spcPts val="0"/>
-              </a:spcAft>
-              <a:tabLst>
-                <a:tab algn="l" pos="0"/>
-                <a:tab algn="l" pos="347040"/>
-                <a:tab algn="l" pos="898200"/>
-                <a:tab algn="l" pos="4027680"/>
-              </a:tabLst>
-            </a:pPr>
-            <a:r>
-              <a:rPr b="1" sz="1400">
-                <a:solidFill>
-                  <a:srgbClr val="000000"/>
-                </a:solidFill>
-                <a:latin typeface="Nimbus Roman"/>
-              </a:rPr>
-              <a:t>		Refrigerator</a:t>
-            </a:r>
-          </a:p>
-          <a:p>
-            <a:pPr>
-              <a:lnSpc>
-                <a:spcPct val="100000"/>
-              </a:lnSpc>
-              <a:spcBef>
-                <a:spcPts val="700"/>
-              </a:spcBef>
-              <a:spcAft>
-                <a:spcPts val="0"/>
-              </a:spcAft>
-              <a:tabLst>
-                <a:tab algn="l" pos="0"/>
-                <a:tab algn="l" pos="347040"/>
-                <a:tab algn="l" pos="898200"/>
-                <a:tab algn="l" pos="4027680"/>
-              </a:tabLst>
-            </a:pPr>
-            <a:r>
-              <a:rPr b="1" sz="1400">
-                <a:solidFill>
-                  <a:srgbClr val="000000"/>
-                </a:solidFill>
-                <a:latin typeface="Nimbus Roman"/>
-              </a:rPr>
-              <a:t>		Washer/Dryer</a:t>
-            </a:r>
-          </a:p>
-          <a:p>
-            <a:pPr>
-              <a:lnSpc>
-                <a:spcPct val="100000"/>
-              </a:lnSpc>
-              <a:spcBef>
-                <a:spcPts val="700"/>
-              </a:spcBef>
-              <a:spcAft>
-                <a:spcPts val="0"/>
-              </a:spcAft>
-              <a:tabLst>
-                <a:tab algn="l" pos="0"/>
-                <a:tab algn="l" pos="347040"/>
-                <a:tab algn="l" pos="898200"/>
-                <a:tab algn="l" pos="4027680"/>
-              </a:tabLst>
-            </a:pPr>
-            <a:r>
-              <a:rPr b="1" sz="1400">
-                <a:solidFill>
-                  <a:srgbClr val="000000"/>
-                </a:solidFill>
-                <a:latin typeface="Nimbus Roman"/>
-              </a:rPr>
-              <a:t>		Deck</a:t>
-            </a:r>
-          </a:p>
-          <a:p>
-            <a:pPr>
-              <a:lnSpc>
-                <a:spcPct val="100000"/>
-              </a:lnSpc>
-              <a:spcBef>
-                <a:spcPts val="700"/>
-              </a:spcBef>
-              <a:spcAft>
-                <a:spcPts val="0"/>
-              </a:spcAft>
-              <a:tabLst>
-                <a:tab algn="l" pos="0"/>
-                <a:tab algn="l" pos="347040"/>
-                <a:tab algn="l" pos="898200"/>
-                <a:tab algn="l" pos="4027680"/>
-              </a:tabLst>
-            </a:pPr>
-            <a:r>
-              <a:rPr b="1" sz="1400">
-                <a:solidFill>
-                  <a:srgbClr val="000000"/>
-                </a:solidFill>
-                <a:latin typeface="Nimbus Roman"/>
-              </a:rPr>
-              <a:t>		Private Yard</a:t>
-            </a:r>
-          </a:p>
-          <a:p>
-            <a:pPr>
-              <a:lnSpc>
-                <a:spcPct val="100000"/>
-              </a:lnSpc>
-              <a:spcBef>
-                <a:spcPts val="700"/>
-              </a:spcBef>
-              <a:spcAft>
-                <a:spcPts val="0"/>
-              </a:spcAft>
-              <a:tabLst>
-                <a:tab algn="l" pos="0"/>
-                <a:tab algn="l" pos="347040"/>
-                <a:tab algn="l" pos="898200"/>
-                <a:tab algn="l" pos="4027680"/>
-              </a:tabLst>
-            </a:pPr>
-            <a:r>
-              <a:rPr b="1" sz="1400">
-                <a:solidFill>
-                  <a:srgbClr val="000000"/>
-                </a:solidFill>
-                <a:latin typeface="Nimbus Roman"/>
-              </a:rPr>
-              <a:t>		Pet Friendly</a:t>
-            </a:r>
-          </a:p>
-          <a:p>
-            <a:pPr>
-              <a:lnSpc>
-                <a:spcPct val="100000"/>
-              </a:lnSpc>
-              <a:spcBef>
-                <a:spcPts val="700"/>
-              </a:spcBef>
-              <a:spcAft>
-                <a:spcPts val="0"/>
-              </a:spcAft>
-              <a:tabLst>
-                <a:tab algn="l" pos="0"/>
-                <a:tab algn="l" pos="347040"/>
-                <a:tab algn="l" pos="898200"/>
-                <a:tab algn="l" pos="4027680"/>
-              </a:tabLst>
-            </a:pPr>
-            <a:r>
-              <a:rPr b="1" sz="1400">
-                <a:solidFill>
-                  <a:srgbClr val="000000"/>
-                </a:solidFill>
-                <a:latin typeface="Nimbus Roman"/>
-              </a:rPr>
-              <a:t>		Rental Friendly</a:t>
+              <a:t>Age:		42 Years</a:t>
             </a:r>
           </a:p>
           <a:p>
@@ -2613,7 +2613,7 @@
                 </a:solidFill>
                 <a:latin typeface="Nimbus Roman"/>
               </a:rPr>
-              <a:t>Home (1,721 sq. ft.)</a:t>
+              <a:t>Main &amp; Upper (1,046 sq. ft.)</a:t>
             </a:r>
             <a:endParaRPr lang="en-CA" sz="1400" b="0" u="none" strike="noStrike">
               <a:solidFill>
@@ -2736,7 +2736,7 @@
                 </a:solidFill>
                 <a:latin typeface="Nimbus Roman"/>
               </a:rPr>
-              <a:t>Bedroom	12' 7" x 12' 9" 8' 9" x 9' 9"</a:t>
+              <a:t>Bedroom	12' 7" x 12'</a:t>
             </a:r>
           </a:p>
           <a:p>
@@ -2755,7 +2755,7 @@
                 </a:solidFill>
                 <a:latin typeface="Nimbus Roman"/>
               </a:rPr>
-              <a:t>Bathroom - Full	4 PCE</a:t>
+              <a:t>Bathroom	4 piece</a:t>
             </a:r>
           </a:p>
           <a:p>
@@ -2774,7 +2774,7 @@
                 </a:solidFill>
                 <a:latin typeface="Nimbus Roman"/>
               </a:rPr>
-              <a:t>Ensuite - Half	2 PCE</a:t>
+              <a:t>Ensuite	2 piece</a:t>
             </a:r>
           </a:p>
           <a:p>
@@ -2793,9 +2793,29 @@
                 </a:solidFill>
                 <a:latin typeface="Nimbus Roman"/>
               </a:rPr>
-              <a:t>Laundry	9' 3" x 3' </a:t>
-            </a:r>
-          </a:p>
+              <a:t>Laundry	9' 3" x 3'</a:t>
+            </a:r>
+          </a:p>
+          <a:p>
+            <a:pPr algn="ctr">
+              <a:lnSpc>
+                <a:spcPct val="150000"/>
+              </a:lnSpc>
+              <a:tabLst>
+                <a:tab algn="l" pos="1619280"/>
+              </a:tabLst>
+            </a:pPr>
+            <a:r>
+              <a:rPr b="1" sz="1400" i="1">
+                <a:solidFill>
+                  <a:srgbClr val="000000"/>
+                </a:solidFill>
+                <a:latin typeface="Nimbus Roman"/>
+              </a:rPr>
+              <a:t>Lower (675 sq. ft.)</a:t>
+            </a:r>
+          </a:p>
+          <a:p/>
           <a:p>
             <a:pPr>
               <a:lnSpc>
@@ -2812,7 +2832,7 @@
                 </a:solidFill>
                 <a:latin typeface="Nimbus Roman"/>
               </a:rPr>
-              <a:t>Family Room	19' 3" x 12' 6"</a:t>
+              <a:t>Bedroom	9' 8" x 9' 9"</a:t>
             </a:r>
           </a:p>
           <a:p>
@@ -2831,7 +2851,26 @@
                 </a:solidFill>
                 <a:latin typeface="Nimbus Roman"/>
               </a:rPr>
-              <a:t>Storage	18' 9" x 6' </a:t>
+              <a:t>Family Room	19' 3" x 12' 6"</a:t>
+            </a:r>
+          </a:p>
+          <a:p>
+            <a:pPr>
+              <a:lnSpc>
+                <a:spcPct val="150000"/>
+              </a:lnSpc>
+              <a:tabLst>
+                <a:tab algn="l" pos="1619280"/>
+              </a:tabLst>
+            </a:pPr>
+            <a:r>
+              <a:rPr b="1" sz="1400">
+                <a:solidFill>
+                  <a:srgbClr val="000000"/>
+                </a:solidFill>
+                <a:latin typeface="Nimbus Roman"/>
+              </a:rPr>
+              <a:t>Storage	18' 9" x 6'</a:t>
             </a:r>
           </a:p>
         </p:txBody>
@@ -2883,7 +2922,7 @@
       </p:sp>
       <p:pic>
         <p:nvPicPr>
-          <p:cNvPr id="43" name="Picture 42" descr="DSC03411.jpg"/>
+          <p:cNvPr id="43" name="Picture 42" descr="DSC03388.jpg"/>
           <p:cNvPicPr>
             <a:picLocks noChangeAspect="1"/>
           </p:cNvPicPr>
@@ -2891,7 +2930,7 @@
         </p:nvPicPr>
         <p:blipFill>
           <a:blip r:embed="rId3"/>
-          <a:srcRect l="6919" r="6919"/>
+          <a:srcRect l="6818" r="6818"/>
           <a:stretch>
             <a:fillRect/>
           </a:stretch>
@@ -2908,7 +2947,7 @@
       </p:pic>
       <p:pic>
         <p:nvPicPr>
-          <p:cNvPr id="44" name="Picture 43" descr="DSC03388.jpg"/>
+          <p:cNvPr id="44" name="Picture 43" descr="DSC03411.jpg"/>
           <p:cNvPicPr>
             <a:picLocks noChangeAspect="1"/>
           </p:cNvPicPr>
@@ -2916,7 +2955,7 @@
         </p:nvPicPr>
         <p:blipFill>
           <a:blip r:embed="rId4"/>
-          <a:srcRect l="8510" r="8510"/>
+          <a:srcRect l="8607" r="8607"/>
           <a:stretch>
             <a:fillRect/>
           </a:stretch>
@@ -2933,7 +2972,7 @@
       </p:pic>
       <p:pic>
         <p:nvPicPr>
-          <p:cNvPr id="45" name="Picture 44" descr="DSC03399.jpg"/>
+          <p:cNvPr id="45" name="Picture 44" descr="DSC03428.jpg"/>
           <p:cNvPicPr>
             <a:picLocks noChangeAspect="1"/>
           </p:cNvPicPr>
@@ -2941,7 +2980,7 @@
         </p:nvPicPr>
         <p:blipFill>
           <a:blip r:embed="rId5"/>
-          <a:srcRect l="8910" r="8910"/>
+          <a:srcRect l="8814" r="8814"/>
           <a:stretch>
             <a:fillRect/>
           </a:stretch>
@@ -2958,7 +2997,7 @@
       </p:pic>
       <p:pic>
         <p:nvPicPr>
-          <p:cNvPr id="46" name="Picture 45" descr="DSC03434.jpg"/>
+          <p:cNvPr id="46" name="Picture 45" descr="DSC03399.jpg"/>
           <p:cNvPicPr>
             <a:picLocks noChangeAspect="1"/>
           </p:cNvPicPr>
@@ -2983,7 +3022,7 @@
       </p:pic>
       <p:pic>
         <p:nvPicPr>
-          <p:cNvPr id="47" name="Picture 46" descr="DSC03417.jpg"/>
+          <p:cNvPr id="47" name="Picture 46" descr="DSC03408.jpg"/>
           <p:cNvPicPr>
             <a:picLocks noChangeAspect="1"/>
           </p:cNvPicPr>

</xml_diff>

<commit_message>
summaro block spacing works well now
</commit_message>
<xml_diff>
--- a/test_output.pptx
+++ b/test_output.pptx
@@ -938,7 +938,7 @@
                 </a:solidFill>
                 <a:latin typeface="Nimbus Roman"/>
               </a:rPr>
-              <a:t>Open green outlook with mountain views, adding a peaceful backdrop to everyday living.</a:t>
+              <a:t>Fenced backyard with mature shade and a peaceful setting backing onto open green space.</a:t>
             </a:r>
             <a:endParaRPr lang="en-CA" sz="1000" b="0" u="none" strike="noStrike">
               <a:solidFill>
@@ -994,7 +994,7 @@
                 </a:solidFill>
                 <a:latin typeface="Nimbus Roman"/>
               </a:rPr>
-              <a:t>Dining area connects seamlessly to the kitchen and opens directly onto the sunny deck.</a:t>
+              <a:t>Open green space and mountain views extend the sense of privacy behind the home.</a:t>
             </a:r>
             <a:endParaRPr lang="en-CA" sz="1000" b="0" u="none" strike="noStrike">
               <a:solidFill>
@@ -1050,7 +1050,7 @@
                 </a:solidFill>
                 <a:latin typeface="Nimbus Roman"/>
               </a:rPr>
-              <a:t>Bright kitchen with peninsula seating, ample prep space, and leafy views from the window.</a:t>
+              <a:t>Bright dining area connects seamlessly to the deck for easy everyday indoor-outdoor living.</a:t>
             </a:r>
             <a:endParaRPr lang="en-CA" sz="1000" b="0" u="none" strike="noStrike">
               <a:solidFill>
@@ -1106,7 +1106,7 @@
                 </a:solidFill>
                 <a:latin typeface="Nimbus Roman"/>
               </a:rPr>
-              <a:t>Fenced backyard with mature shade, open lawn, and a pleasant green outlook beyond.</a:t>
+              <a:t>Light-filled kitchen offers efficient workspace and pleasant outlooks to the greenery.</a:t>
             </a:r>
             <a:endParaRPr lang="en-CA" sz="1000" b="0" u="none" strike="noStrike">
               <a:solidFill>
@@ -1162,7 +1162,7 @@
                 </a:solidFill>
                 <a:latin typeface="Nimbus Roman"/>
               </a:rPr>
-              <a:t>Welcoming living room filled with natural light from the large front-facing window.</a:t>
+              <a:t>Inviting living room filled with natural light and comfortable space to gather or unwind.</a:t>
             </a:r>
             <a:endParaRPr lang="en-CA" sz="1000" b="0" u="none" strike="noStrike">
               <a:solidFill>
@@ -1256,6 +1256,9 @@
           </a:bodyPr>
           <a:p>
             <a:pPr marL="216000" indent="-216000">
+              <a:lnSpc>
+                <a:spcPct val="100000"/>
+              </a:lnSpc>
               <a:spcBef>
                 <a:spcPts val="0"/>
               </a:spcBef>
@@ -1276,7 +1279,7 @@
                 </a:solidFill>
                 <a:latin typeface="Nimbus Roman"/>
               </a:rPr>
-              <a:t>Bright and functional cathedral-entry townhome offering over 1,700 sq. ft. across a flexible three-level split design.</a:t>
+              <a:t>This bright cathedral-entry townhome offers more than 1,700 square feet of flexible living space in a convenient Brocklehurst location.</a:t>
             </a:r>
             <a:endParaRPr lang="en-CA" sz="1100" b="0" u="none" strike="noStrike">
               <a:solidFill>
@@ -1289,8 +1292,11 @@
           </a:p>
           <a:p>
             <a:pPr marL="216000" indent="-216000">
+              <a:lnSpc>
+                <a:spcPct val="100000"/>
+              </a:lnSpc>
               <a:spcBef>
-                <a:spcPts val="600"/>
+                <a:spcPts val="1800"/>
               </a:spcBef>
               <a:spcAft>
                 <a:spcPts val="0"/>
@@ -1309,13 +1315,16 @@
                 </a:solidFill>
                 <a:latin typeface="Nimbus Roman"/>
               </a:rPr>
-              <a:t>Thoughtfully renovated in 2012 with updates to the kitchen, flooring, appliances, windows, roof, lighting, decks, and railings.</a:t>
+              <a:t>Thoughtful 2012 renovations updated the kitchen, flooring, appliances, windows, roof, light fixtures, decks, and railings for lasting appeal.</a:t>
             </a:r>
           </a:p>
           <a:p>
             <a:pPr marL="216000" indent="-216000">
+              <a:lnSpc>
+                <a:spcPct val="100000"/>
+              </a:lnSpc>
               <a:spcBef>
-                <a:spcPts val="600"/>
+                <a:spcPts val="1800"/>
               </a:spcBef>
               <a:spcAft>
                 <a:spcPts val="0"/>
@@ -1334,13 +1343,16 @@
                 </a:solidFill>
                 <a:latin typeface="Nimbus Roman"/>
               </a:rPr>
-              <a:t>The sunny dining area opens to a sundeck overlooking the fenced yard and peaceful green space beyond.</a:t>
+              <a:t>The sunny dining area opens to a covered sundeck overlooking the fenced yard and peaceful green space beyond.</a:t>
             </a:r>
           </a:p>
           <a:p>
             <a:pPr marL="216000" indent="-216000">
+              <a:lnSpc>
+                <a:spcPct val="100000"/>
+              </a:lnSpc>
               <a:spcBef>
-                <a:spcPts val="600"/>
+                <a:spcPts val="1800"/>
               </a:spcBef>
               <a:spcAft>
                 <a:spcPts val="0"/>
@@ -1359,13 +1371,16 @@
                 </a:solidFill>
                 <a:latin typeface="Nimbus Roman"/>
               </a:rPr>
-              <a:t>A versatile layout includes main floor laundry, a spacious family room, and a lower-level bedroom ideal for guests or a home office.</a:t>
+              <a:t>A spacious family room and basement bedroom provide versatile options for guests, a home office, hobbies, or recreation.</a:t>
             </a:r>
           </a:p>
           <a:p>
             <a:pPr marL="216000" indent="-216000">
+              <a:lnSpc>
+                <a:spcPct val="100000"/>
+              </a:lnSpc>
               <a:spcBef>
-                <a:spcPts val="600"/>
+                <a:spcPts val="1800"/>
               </a:spcBef>
               <a:spcAft>
                 <a:spcPts val="0"/>
@@ -1384,13 +1399,16 @@
                 </a:solidFill>
                 <a:latin typeface="Nimbus Roman"/>
               </a:rPr>
-              <a:t>The double attached garage provides workshop potential and rear yard access, complemented by driveway parking and an assigned stall.</a:t>
+              <a:t>The double attached garage includes workshop space and rear yard pass-through access, complemented by four total parking spaces.</a:t>
             </a:r>
           </a:p>
           <a:p>
             <a:pPr marL="216000" indent="-216000">
+              <a:lnSpc>
+                <a:spcPct val="100000"/>
+              </a:lnSpc>
               <a:spcBef>
-                <a:spcPts val="600"/>
+                <a:spcPts val="1800"/>
               </a:spcBef>
               <a:spcAft>
                 <a:spcPts val="0"/>
@@ -1409,7 +1427,7 @@
                 </a:solidFill>
                 <a:latin typeface="Nimbus Roman"/>
               </a:rPr>
-              <a:t>Pet- and rental-friendly in Brocklehurst, close to schools, shopping, McArthur Island Park, and the scenic River’s Trail.</a:t>
+              <a:t>Pet- and rental-friendly, this home is close to schools, shopping, McArthur Island Park, and the scenic River’s Trail.</a:t>
             </a:r>
           </a:p>
         </p:txBody>
@@ -1491,7 +1509,7 @@
                 </a:solidFill>
                 <a:latin typeface="Nimbus Roman"/>
               </a:rPr>
-              <a:t>Bright Brocklehurst Townhome With Greenbelt Views And Room To Grow</a:t>
+              <a:t>Bright Brocklehurst Living Backing Onto Green Space</a:t>
             </a:r>
             <a:endParaRPr lang="en-CA" sz="1600" b="0" u="none" strike="noStrike">
               <a:solidFill>
@@ -1596,7 +1614,7 @@
       </p:sp>
       <p:pic>
         <p:nvPicPr>
-          <p:cNvPr id="28" name="Picture 27" descr="DSC03355.jpg"/>
+          <p:cNvPr id="28" name="Picture 27" descr="DSC03349.jpg"/>
           <p:cNvPicPr>
             <a:picLocks noChangeAspect="1"/>
           </p:cNvPicPr>
@@ -1621,7 +1639,7 @@
       </p:pic>
       <p:pic>
         <p:nvPicPr>
-          <p:cNvPr id="29" name="Picture 28" descr="DSC03378.jpg"/>
+          <p:cNvPr id="29" name="Picture 28" descr="DSC03355.jpg"/>
           <p:cNvPicPr>
             <a:picLocks noChangeAspect="1"/>
           </p:cNvPicPr>
@@ -1646,7 +1664,7 @@
       </p:pic>
       <p:pic>
         <p:nvPicPr>
-          <p:cNvPr id="30" name="Picture 29" descr="DSC03349.jpg"/>
+          <p:cNvPr id="30" name="Picture 29" descr="DSC03381.jpg"/>
           <p:cNvPicPr>
             <a:picLocks noChangeAspect="1"/>
           </p:cNvPicPr>
@@ -1671,7 +1689,7 @@
       </p:pic>
       <p:pic>
         <p:nvPicPr>
-          <p:cNvPr id="31" name="Picture 30" descr="DSC03381.jpg"/>
+          <p:cNvPr id="31" name="Picture 30" descr="DSC03378.jpg"/>
           <p:cNvPicPr>
             <a:picLocks noChangeAspect="1"/>
           </p:cNvPicPr>
@@ -1814,7 +1832,7 @@
                 </a:solidFill>
                 <a:latin typeface="Nimbus Roman"/>
               </a:rPr>
-              <a:t>Covered deck with room for grilling, dining, and enjoying the private backyard setting.</a:t>
+              <a:t>Covered deck offers room to dine, grill, and relax while overlooking mature trees.</a:t>
             </a:r>
             <a:endParaRPr lang="en-CA" sz="1000" b="0" u="none" strike="noStrike">
               <a:solidFill>
@@ -1870,7 +1888,7 @@
                 </a:solidFill>
                 <a:latin typeface="Nimbus Roman"/>
               </a:rPr>
-              <a:t>Spacious primary bedroom featuring soft carpet, natural light, and a stylish accent wall.</a:t>
+              <a:t>Spacious primary bedroom features soft finishes and abundant natural light for a calm.</a:t>
             </a:r>
             <a:endParaRPr lang="en-CA" sz="1000" b="0" u="none" strike="noStrike">
               <a:solidFill>
@@ -1926,7 +1944,7 @@
                 </a:solidFill>
                 <a:latin typeface="Nimbus Roman"/>
               </a:rPr>
-              <a:t>Flexible lower-level rec room suited to media, workouts, hobbies, or work-from-home needs.</a:t>
+              <a:t>Full bathroom with natural light and a clean, functional design for daily ease.</a:t>
             </a:r>
             <a:endParaRPr lang="en-CA" sz="1000" b="0" u="none" strike="noStrike">
               <a:solidFill>
@@ -1982,7 +2000,7 @@
                 </a:solidFill>
                 <a:latin typeface="Nimbus Roman"/>
               </a:rPr>
-              <a:t>Versatile bedroom works equally well for guests, a nursery, or a bright home office.</a:t>
+              <a:t>Large lower-level rec room offers flexible space for work, fitness, media, or play.</a:t>
             </a:r>
             <a:endParaRPr lang="en-CA" sz="1000" b="0" u="none" strike="noStrike">
               <a:solidFill>
@@ -2038,7 +2056,7 @@
                 </a:solidFill>
                 <a:latin typeface="Nimbus Roman"/>
               </a:rPr>
-              <a:t>Clean, bright full bathroom with natural light and a practical everyday layout.</a:t>
+              <a:t>Generous bedroom with soft natural tones and convenient access nearby for added comfort.</a:t>
             </a:r>
             <a:endParaRPr lang="en-CA" sz="1000" b="0" u="none" strike="noStrike">
               <a:solidFill>
@@ -2233,7 +2251,7 @@
                 </a:solidFill>
                 <a:latin typeface="Nimbus Roman"/>
               </a:rPr>
-              <a:t>Style:		Cathedral Entry</a:t>
+              <a:t>Style:	Cathedral Entry</a:t>
             </a:r>
           </a:p>
           <a:p>
@@ -2541,35 +2559,7 @@
                 </a:solidFill>
                 <a:latin typeface="Nimbus Roman"/>
               </a:rPr>
-              <a:t>Age:		42 Years</a:t>
-            </a:r>
-          </a:p>
-          <a:p>
-            <a:pPr>
-              <a:lnSpc>
-                <a:spcPct val="100000"/>
-              </a:lnSpc>
-              <a:spcBef>
-                <a:spcPts val="2100"/>
-              </a:spcBef>
-              <a:spcAft>
-                <a:spcPts val="0"/>
-              </a:spcAft>
-              <a:tabLst>
-                <a:tab algn="l" pos="0"/>
-                <a:tab algn="l" pos="347040"/>
-                <a:tab algn="l" pos="898200"/>
-                <a:tab algn="l" pos="4027680"/>
-              </a:tabLst>
-            </a:pPr>
-            <a:r>
-              <a:rPr b="1" sz="1400">
-                <a:solidFill>
-                  <a:srgbClr val="000000"/>
-                </a:solidFill>
-                <a:latin typeface="Nimbus Roman"/>
-              </a:rPr>
-              <a:t>Taxes:		$3,145 (2025)</a:t>
+              <a:t>Taxes:	$3,145 (2025)</a:t>
             </a:r>
           </a:p>
         </p:txBody>
@@ -2597,34 +2587,6 @@
           <a:bodyPr lIns="90000" rIns="90000" tIns="45000" bIns="45000" anchor="t">
             <a:spAutoFit/>
           </a:bodyPr>
-          <a:p>
-            <a:pPr algn="ctr">
-              <a:lnSpc>
-                <a:spcPct val="150000"/>
-              </a:lnSpc>
-              <a:tabLst>
-                <a:tab algn="l" pos="1619280"/>
-              </a:tabLst>
-            </a:pPr>
-            <a:r>
-              <a:rPr b="1" sz="1400" i="1">
-                <a:solidFill>
-                  <a:srgbClr val="000000"/>
-                </a:solidFill>
-                <a:latin typeface="Nimbus Roman"/>
-              </a:rPr>
-              <a:t>Main &amp; Upper (1,046 sq. ft.)</a:t>
-            </a:r>
-            <a:endParaRPr lang="en-CA" sz="1400" b="0" u="none" strike="noStrike">
-              <a:solidFill>
-                <a:srgbClr val="000000"/>
-              </a:solidFill>
-              <a:effectLst/>
-              <a:uFillTx/>
-              <a:latin typeface="Arial"/>
-            </a:endParaRPr>
-          </a:p>
-          <a:p/>
           <a:p>
             <a:pPr>
               <a:lnSpc>
@@ -2634,244 +2596,14 @@
                 <a:tab algn="l" pos="1619280"/>
               </a:tabLst>
             </a:pPr>
-            <a:r>
-              <a:rPr b="1" sz="1400">
-                <a:solidFill>
-                  <a:srgbClr val="000000"/>
-                </a:solidFill>
-                <a:latin typeface="Nimbus Roman"/>
-              </a:rPr>
-              <a:t>Kitchen	10' 4" x 13' 11"</a:t>
-            </a:r>
-          </a:p>
-          <a:p>
-            <a:pPr>
-              <a:lnSpc>
-                <a:spcPct val="150000"/>
-              </a:lnSpc>
-              <a:tabLst>
-                <a:tab algn="l" pos="1619280"/>
-              </a:tabLst>
-            </a:pPr>
-            <a:r>
-              <a:rPr b="1" sz="1400">
-                <a:solidFill>
-                  <a:srgbClr val="000000"/>
-                </a:solidFill>
-                <a:latin typeface="Nimbus Roman"/>
-              </a:rPr>
-              <a:t>Living Room	14' 4" x 14' 9"</a:t>
-            </a:r>
-          </a:p>
-          <a:p>
-            <a:pPr>
-              <a:lnSpc>
-                <a:spcPct val="150000"/>
-              </a:lnSpc>
-              <a:tabLst>
-                <a:tab algn="l" pos="1619280"/>
-              </a:tabLst>
-            </a:pPr>
-            <a:r>
-              <a:rPr b="1" sz="1400">
-                <a:solidFill>
-                  <a:srgbClr val="000000"/>
-                </a:solidFill>
-                <a:latin typeface="Nimbus Roman"/>
-              </a:rPr>
-              <a:t>Dining Room	9' 2" x 8' 9"</a:t>
-            </a:r>
-          </a:p>
-          <a:p>
-            <a:pPr>
-              <a:lnSpc>
-                <a:spcPct val="150000"/>
-              </a:lnSpc>
-              <a:tabLst>
-                <a:tab algn="l" pos="1619280"/>
-              </a:tabLst>
-            </a:pPr>
-            <a:r>
-              <a:rPr b="1" sz="1400">
-                <a:solidFill>
-                  <a:srgbClr val="000000"/>
-                </a:solidFill>
-                <a:latin typeface="Nimbus Roman"/>
-              </a:rPr>
-              <a:t>Primary Bedroom	11' 8" x 10' 6"</a:t>
-            </a:r>
-          </a:p>
-          <a:p>
-            <a:pPr>
-              <a:lnSpc>
-                <a:spcPct val="150000"/>
-              </a:lnSpc>
-              <a:tabLst>
-                <a:tab algn="l" pos="1619280"/>
-              </a:tabLst>
-            </a:pPr>
-            <a:r>
-              <a:rPr b="1" sz="1400">
-                <a:solidFill>
-                  <a:srgbClr val="000000"/>
-                </a:solidFill>
-                <a:latin typeface="Nimbus Roman"/>
-              </a:rPr>
-              <a:t>Bedroom	8' 3" x 8' 9"</a:t>
-            </a:r>
-          </a:p>
-          <a:p>
-            <a:pPr>
-              <a:lnSpc>
-                <a:spcPct val="150000"/>
-              </a:lnSpc>
-              <a:tabLst>
-                <a:tab algn="l" pos="1619280"/>
-              </a:tabLst>
-            </a:pPr>
-            <a:r>
-              <a:rPr b="1" sz="1400">
-                <a:solidFill>
-                  <a:srgbClr val="000000"/>
-                </a:solidFill>
-                <a:latin typeface="Nimbus Roman"/>
-              </a:rPr>
-              <a:t>Bedroom	12' 7" x 12'</a:t>
-            </a:r>
-          </a:p>
-          <a:p>
-            <a:pPr>
-              <a:lnSpc>
-                <a:spcPct val="150000"/>
-              </a:lnSpc>
-              <a:tabLst>
-                <a:tab algn="l" pos="1619280"/>
-              </a:tabLst>
-            </a:pPr>
-            <a:r>
-              <a:rPr b="1" sz="1400">
-                <a:solidFill>
-                  <a:srgbClr val="000000"/>
-                </a:solidFill>
-                <a:latin typeface="Nimbus Roman"/>
-              </a:rPr>
-              <a:t>Bathroom	4 piece</a:t>
-            </a:r>
-          </a:p>
-          <a:p>
-            <a:pPr>
-              <a:lnSpc>
-                <a:spcPct val="150000"/>
-              </a:lnSpc>
-              <a:tabLst>
-                <a:tab algn="l" pos="1619280"/>
-              </a:tabLst>
-            </a:pPr>
-            <a:r>
-              <a:rPr b="1" sz="1400">
-                <a:solidFill>
-                  <a:srgbClr val="000000"/>
-                </a:solidFill>
-                <a:latin typeface="Nimbus Roman"/>
-              </a:rPr>
-              <a:t>Ensuite	2 piece</a:t>
-            </a:r>
-          </a:p>
-          <a:p>
-            <a:pPr>
-              <a:lnSpc>
-                <a:spcPct val="150000"/>
-              </a:lnSpc>
-              <a:tabLst>
-                <a:tab algn="l" pos="1619280"/>
-              </a:tabLst>
-            </a:pPr>
-            <a:r>
-              <a:rPr b="1" sz="1400">
-                <a:solidFill>
-                  <a:srgbClr val="000000"/>
-                </a:solidFill>
-                <a:latin typeface="Nimbus Roman"/>
-              </a:rPr>
-              <a:t>Laundry	9' 3" x 3'</a:t>
-            </a:r>
-          </a:p>
-          <a:p>
-            <a:pPr algn="ctr">
-              <a:lnSpc>
-                <a:spcPct val="150000"/>
-              </a:lnSpc>
-              <a:tabLst>
-                <a:tab algn="l" pos="1619280"/>
-              </a:tabLst>
-            </a:pPr>
-            <a:r>
-              <a:rPr b="1" sz="1400" i="1">
-                <a:solidFill>
-                  <a:srgbClr val="000000"/>
-                </a:solidFill>
-                <a:latin typeface="Nimbus Roman"/>
-              </a:rPr>
-              <a:t>Lower (675 sq. ft.)</a:t>
-            </a:r>
-          </a:p>
-          <a:p/>
-          <a:p>
-            <a:pPr>
-              <a:lnSpc>
-                <a:spcPct val="150000"/>
-              </a:lnSpc>
-              <a:tabLst>
-                <a:tab algn="l" pos="1619280"/>
-              </a:tabLst>
-            </a:pPr>
-            <a:r>
-              <a:rPr b="1" sz="1400">
-                <a:solidFill>
-                  <a:srgbClr val="000000"/>
-                </a:solidFill>
-                <a:latin typeface="Nimbus Roman"/>
-              </a:rPr>
-              <a:t>Bedroom	9' 8" x 9' 9"</a:t>
-            </a:r>
-          </a:p>
-          <a:p>
-            <a:pPr>
-              <a:lnSpc>
-                <a:spcPct val="150000"/>
-              </a:lnSpc>
-              <a:tabLst>
-                <a:tab algn="l" pos="1619280"/>
-              </a:tabLst>
-            </a:pPr>
-            <a:r>
-              <a:rPr b="1" sz="1400">
-                <a:solidFill>
-                  <a:srgbClr val="000000"/>
-                </a:solidFill>
-                <a:latin typeface="Nimbus Roman"/>
-              </a:rPr>
-              <a:t>Family Room	19' 3" x 12' 6"</a:t>
-            </a:r>
-          </a:p>
-          <a:p>
-            <a:pPr>
-              <a:lnSpc>
-                <a:spcPct val="150000"/>
-              </a:lnSpc>
-              <a:tabLst>
-                <a:tab algn="l" pos="1619280"/>
-              </a:tabLst>
-            </a:pPr>
-            <a:r>
-              <a:rPr b="1" sz="1400">
-                <a:solidFill>
-                  <a:srgbClr val="000000"/>
-                </a:solidFill>
-                <a:latin typeface="Nimbus Roman"/>
-              </a:rPr>
-              <a:t>Storage	18' 9" x 6'</a:t>
-            </a:r>
+            <a:endParaRPr lang="en-CA" sz="1400" b="0" u="none" strike="noStrike">
+              <a:solidFill>
+                <a:srgbClr val="000000"/>
+              </a:solidFill>
+              <a:effectLst/>
+              <a:uFillTx/>
+              <a:latin typeface="Arial"/>
+            </a:endParaRPr>
           </a:p>
         </p:txBody>
       </p:sp>
@@ -2972,7 +2704,7 @@
       </p:pic>
       <p:pic>
         <p:nvPicPr>
-          <p:cNvPr id="45" name="Picture 44" descr="DSC03428.jpg"/>
+          <p:cNvPr id="45" name="Picture 44" descr="DSC03399.jpg"/>
           <p:cNvPicPr>
             <a:picLocks noChangeAspect="1"/>
           </p:cNvPicPr>
@@ -2980,7 +2712,7 @@
         </p:nvPicPr>
         <p:blipFill>
           <a:blip r:embed="rId5"/>
-          <a:srcRect l="8814" r="8814"/>
+          <a:srcRect l="8910" r="8910"/>
           <a:stretch>
             <a:fillRect/>
           </a:stretch>
@@ -2997,7 +2729,7 @@
       </p:pic>
       <p:pic>
         <p:nvPicPr>
-          <p:cNvPr id="46" name="Picture 45" descr="DSC03399.jpg"/>
+          <p:cNvPr id="46" name="Picture 45" descr="DSC03423.jpg"/>
           <p:cNvPicPr>
             <a:picLocks noChangeAspect="1"/>
           </p:cNvPicPr>
@@ -3005,7 +2737,7 @@
         </p:nvPicPr>
         <p:blipFill>
           <a:blip r:embed="rId6"/>
-          <a:srcRect l="13800" r="13800"/>
+          <a:srcRect l="13715" r="13715"/>
           <a:stretch>
             <a:fillRect/>
           </a:stretch>
@@ -3022,7 +2754,7 @@
       </p:pic>
       <p:pic>
         <p:nvPicPr>
-          <p:cNvPr id="47" name="Picture 46" descr="DSC03408.jpg"/>
+          <p:cNvPr id="47" name="Picture 46" descr="DSC03428.jpg"/>
           <p:cNvPicPr>
             <a:picLocks noChangeAspect="1"/>
           </p:cNvPicPr>
@@ -3030,7 +2762,7 @@
         </p:nvPicPr>
         <p:blipFill>
           <a:blip r:embed="rId7"/>
-          <a:srcRect l="6917" r="6917"/>
+          <a:srcRect l="6816" r="6816"/>
           <a:stretch>
             <a:fillRect/>
           </a:stretch>

</xml_diff>

<commit_message>
Fixed room block generation
</commit_message>
<xml_diff>
--- a/test_output.pptx
+++ b/test_output.pptx
@@ -938,7 +938,7 @@
                 </a:solidFill>
                 <a:latin typeface="Nimbus Roman"/>
               </a:rPr>
-              <a:t>Fenced backyard with mature shade and a peaceful setting backing onto open green space.</a:t>
+              <a:t>Wide open field and mountain views create a peaceful backdrop just beyond the home.</a:t>
             </a:r>
             <a:endParaRPr lang="en-CA" sz="1000" b="0" u="none" strike="noStrike">
               <a:solidFill>
@@ -994,7 +994,7 @@
                 </a:solidFill>
                 <a:latin typeface="Nimbus Roman"/>
               </a:rPr>
-              <a:t>Open green space and mountain views extend the sense of privacy behind the home.</a:t>
+              <a:t>Spacious primary bedroom with a striking accent wall and great natural light.</a:t>
             </a:r>
             <a:endParaRPr lang="en-CA" sz="1000" b="0" u="none" strike="noStrike">
               <a:solidFill>
@@ -1050,7 +1050,7 @@
                 </a:solidFill>
                 <a:latin typeface="Nimbus Roman"/>
               </a:rPr>
-              <a:t>Bright dining area connects seamlessly to the deck for easy everyday indoor-outdoor living.</a:t>
+              <a:t>Fenced backyard opens toward lush green space and a broad field beyond.</a:t>
             </a:r>
             <a:endParaRPr lang="en-CA" sz="1000" b="0" u="none" strike="noStrike">
               <a:solidFill>
@@ -1106,7 +1106,7 @@
                 </a:solidFill>
                 <a:latin typeface="Nimbus Roman"/>
               </a:rPr>
-              <a:t>Light-filled kitchen offers efficient workspace and pleasant outlooks to the greenery.</a:t>
+              <a:t>Sunny dining area connects easily to the covered deck and backyard outlook.</a:t>
             </a:r>
             <a:endParaRPr lang="en-CA" sz="1000" b="0" u="none" strike="noStrike">
               <a:solidFill>
@@ -1162,7 +1162,7 @@
                 </a:solidFill>
                 <a:latin typeface="Nimbus Roman"/>
               </a:rPr>
-              <a:t>Inviting living room filled with natural light and comfortable space to gather or unwind.</a:t>
+              <a:t>Light-filled kitchen offers an efficient layout and calming views of mature greenery.</a:t>
             </a:r>
             <a:endParaRPr lang="en-CA" sz="1000" b="0" u="none" strike="noStrike">
               <a:solidFill>
@@ -1279,7 +1279,7 @@
                 </a:solidFill>
                 <a:latin typeface="Nimbus Roman"/>
               </a:rPr>
-              <a:t>This bright cathedral-entry townhome offers more than 1,700 square feet of flexible living space in a convenient Brocklehurst location.</a:t>
+              <a:t>This bright and functional three-level split townhome offers over 1,700 square feet of well-planned living space in Brocklehurst.</a:t>
             </a:r>
             <a:endParaRPr lang="en-CA" sz="1100" b="0" u="none" strike="noStrike">
               <a:solidFill>
@@ -1315,7 +1315,7 @@
                 </a:solidFill>
                 <a:latin typeface="Nimbus Roman"/>
               </a:rPr>
-              <a:t>Thoughtful 2012 renovations updated the kitchen, flooring, appliances, windows, roof, light fixtures, decks, and railings for lasting appeal.</a:t>
+              <a:t>A 2012 renovation updated the kitchen, flooring, appliances, windows, roof, lighting, decks, and railings for lasting everyday appeal.</a:t>
             </a:r>
           </a:p>
           <a:p>
@@ -1343,7 +1343,7 @@
                 </a:solidFill>
                 <a:latin typeface="Nimbus Roman"/>
               </a:rPr>
-              <a:t>The sunny dining area opens to a covered sundeck overlooking the fenced yard and peaceful green space beyond.</a:t>
+              <a:t>The sunny dining area opens to a covered sundeck overlooking the fenced backyard and peaceful green space beyond.</a:t>
             </a:r>
           </a:p>
           <a:p>
@@ -1371,7 +1371,7 @@
                 </a:solidFill>
                 <a:latin typeface="Nimbus Roman"/>
               </a:rPr>
-              <a:t>A spacious family room and basement bedroom provide versatile options for guests, a home office, hobbies, or recreation.</a:t>
+              <a:t>A flexible four-bedroom layout includes main floor laundry, a generous family room, and excellent storage for busy households.</a:t>
             </a:r>
           </a:p>
           <a:p>
@@ -1399,7 +1399,7 @@
                 </a:solidFill>
                 <a:latin typeface="Nimbus Roman"/>
               </a:rPr>
-              <a:t>The double attached garage includes workshop space and rear yard pass-through access, complemented by four total parking spaces.</a:t>
+              <a:t>The double attached garage includes workshop space and rear yard access, complemented by extra driveway and assigned parking.</a:t>
             </a:r>
           </a:p>
           <a:p>
@@ -1427,7 +1427,7 @@
                 </a:solidFill>
                 <a:latin typeface="Nimbus Roman"/>
               </a:rPr>
-              <a:t>Pet- and rental-friendly, this home is close to schools, shopping, McArthur Island Park, and the scenic River’s Trail.</a:t>
+              <a:t>Pet-friendly and rental-friendly, this home is close to schools, shopping, McArthur Island Park, and River’s Trail.</a:t>
             </a:r>
           </a:p>
         </p:txBody>
@@ -1614,7 +1614,7 @@
       </p:sp>
       <p:pic>
         <p:nvPicPr>
-          <p:cNvPr id="28" name="Picture 27" descr="DSC03349.jpg"/>
+          <p:cNvPr id="28" name="Picture 27" descr="DSC03355.jpg"/>
           <p:cNvPicPr>
             <a:picLocks noChangeAspect="1"/>
           </p:cNvPicPr>
@@ -1639,7 +1639,7 @@
       </p:pic>
       <p:pic>
         <p:nvPicPr>
-          <p:cNvPr id="29" name="Picture 28" descr="DSC03355.jpg"/>
+          <p:cNvPr id="29" name="Picture 28" descr="DSC03411.jpg"/>
           <p:cNvPicPr>
             <a:picLocks noChangeAspect="1"/>
           </p:cNvPicPr>
@@ -1647,7 +1647,7 @@
         </p:nvPicPr>
         <p:blipFill>
           <a:blip r:embed="rId4"/>
-          <a:srcRect l="7407" r="7407"/>
+          <a:srcRect l="7507" r="7507"/>
           <a:stretch>
             <a:fillRect/>
           </a:stretch>
@@ -1664,7 +1664,7 @@
       </p:pic>
       <p:pic>
         <p:nvPicPr>
-          <p:cNvPr id="30" name="Picture 29" descr="DSC03381.jpg"/>
+          <p:cNvPr id="30" name="Picture 29" descr="DSC03378.jpg"/>
           <p:cNvPicPr>
             <a:picLocks noChangeAspect="1"/>
           </p:cNvPicPr>
@@ -1689,7 +1689,7 @@
       </p:pic>
       <p:pic>
         <p:nvPicPr>
-          <p:cNvPr id="31" name="Picture 30" descr="DSC03378.jpg"/>
+          <p:cNvPr id="31" name="Picture 30" descr="DSC03349.jpg"/>
           <p:cNvPicPr>
             <a:picLocks noChangeAspect="1"/>
           </p:cNvPicPr>
@@ -1714,7 +1714,7 @@
       </p:pic>
       <p:pic>
         <p:nvPicPr>
-          <p:cNvPr id="32" name="Picture 31" descr="DSC03372.jpg"/>
+          <p:cNvPr id="32" name="Picture 31" descr="DSC03381.jpg"/>
           <p:cNvPicPr>
             <a:picLocks noChangeAspect="1"/>
           </p:cNvPicPr>
@@ -1722,7 +1722,7 @@
         </p:nvPicPr>
         <p:blipFill>
           <a:blip r:embed="rId7"/>
-          <a:srcRect l="7541" r="7541"/>
+          <a:srcRect l="7442" r="7442"/>
           <a:stretch>
             <a:fillRect/>
           </a:stretch>
@@ -1832,7 +1832,7 @@
                 </a:solidFill>
                 <a:latin typeface="Nimbus Roman"/>
               </a:rPr>
-              <a:t>Covered deck offers room to dine, grill, and relax while overlooking mature trees.</a:t>
+              <a:t>Covered deck provides space to barbeque, relax, and enjoy the leafy setting.</a:t>
             </a:r>
             <a:endParaRPr lang="en-CA" sz="1000" b="0" u="none" strike="noStrike">
               <a:solidFill>
@@ -1888,7 +1888,7 @@
                 </a:solidFill>
                 <a:latin typeface="Nimbus Roman"/>
               </a:rPr>
-              <a:t>Spacious primary bedroom features soft finishes and abundant natural light for a calm.</a:t>
+              <a:t>Bright living room feels welcoming and open with soft natural light throughout.</a:t>
             </a:r>
             <a:endParaRPr lang="en-CA" sz="1000" b="0" u="none" strike="noStrike">
               <a:solidFill>
@@ -1944,7 +1944,7 @@
                 </a:solidFill>
                 <a:latin typeface="Nimbus Roman"/>
               </a:rPr>
-              <a:t>Full bathroom with natural light and a clean, functional design for daily ease.</a:t>
+              <a:t>Clean full bathroom with natural light and timeless neutral finishes.</a:t>
             </a:r>
             <a:endParaRPr lang="en-CA" sz="1000" b="0" u="none" strike="noStrike">
               <a:solidFill>
@@ -2000,7 +2000,7 @@
                 </a:solidFill>
                 <a:latin typeface="Nimbus Roman"/>
               </a:rPr>
-              <a:t>Large lower-level rec room offers flexible space for work, fitness, media, or play.</a:t>
+              <a:t>Neighborhood green space offers an open feel with lovely mountain views nearby.</a:t>
             </a:r>
             <a:endParaRPr lang="en-CA" sz="1000" b="0" u="none" strike="noStrike">
               <a:solidFill>
@@ -2056,7 +2056,7 @@
                 </a:solidFill>
                 <a:latin typeface="Nimbus Roman"/>
               </a:rPr>
-              <a:t>Generous bedroom with soft natural tones and convenient access nearby for added comfort.</a:t>
+              <a:t>Versatile lower-level flex room suits hobbies, workouts, work, or family use.</a:t>
             </a:r>
             <a:endParaRPr lang="en-CA" sz="1000" b="0" u="none" strike="noStrike">
               <a:solidFill>
@@ -2559,6 +2559,34 @@
                 </a:solidFill>
                 <a:latin typeface="Nimbus Roman"/>
               </a:rPr>
+              <a:t>Age:	42 Years</a:t>
+            </a:r>
+          </a:p>
+          <a:p>
+            <a:pPr>
+              <a:lnSpc>
+                <a:spcPct val="100000"/>
+              </a:lnSpc>
+              <a:spcBef>
+                <a:spcPts val="2100"/>
+              </a:spcBef>
+              <a:spcAft>
+                <a:spcPts val="0"/>
+              </a:spcAft>
+              <a:tabLst>
+                <a:tab algn="l" pos="0"/>
+                <a:tab algn="l" pos="347040"/>
+                <a:tab algn="l" pos="898200"/>
+                <a:tab algn="l" pos="4027680"/>
+              </a:tabLst>
+            </a:pPr>
+            <a:r>
+              <a:rPr b="1" sz="1400">
+                <a:solidFill>
+                  <a:srgbClr val="000000"/>
+                </a:solidFill>
+                <a:latin typeface="Nimbus Roman"/>
+              </a:rPr>
               <a:t>Taxes:	$3,145 (2025)</a:t>
             </a:r>
           </a:p>
@@ -2588,7 +2616,7 @@
             <a:spAutoFit/>
           </a:bodyPr>
           <a:p>
-            <a:pPr>
+            <a:pPr algn="ctr">
               <a:lnSpc>
                 <a:spcPct val="150000"/>
               </a:lnSpc>
@@ -2596,6 +2624,15 @@
                 <a:tab algn="l" pos="1619280"/>
               </a:tabLst>
             </a:pPr>
+            <a:r>
+              <a:rPr b="1" sz="1400" i="1">
+                <a:solidFill>
+                  <a:srgbClr val="000000"/>
+                </a:solidFill>
+                <a:latin typeface="Nimbus Roman"/>
+              </a:rPr>
+              <a:t>Main (1,046 sq. ft.)</a:t>
+            </a:r>
             <a:endParaRPr lang="en-CA" sz="1400" b="0" u="none" strike="noStrike">
               <a:solidFill>
                 <a:srgbClr val="000000"/>
@@ -2604,6 +2641,255 @@
               <a:uFillTx/>
               <a:latin typeface="Arial"/>
             </a:endParaRPr>
+          </a:p>
+          <a:p/>
+          <a:p>
+            <a:pPr>
+              <a:lnSpc>
+                <a:spcPct val="150000"/>
+              </a:lnSpc>
+              <a:tabLst>
+                <a:tab algn="l" pos="1619280"/>
+              </a:tabLst>
+            </a:pPr>
+            <a:r>
+              <a:rPr b="1" sz="1400">
+                <a:solidFill>
+                  <a:srgbClr val="000000"/>
+                </a:solidFill>
+                <a:latin typeface="Nimbus Roman"/>
+              </a:rPr>
+              <a:t>Kitchen	10' 4" x 13' 11"</a:t>
+            </a:r>
+          </a:p>
+          <a:p>
+            <a:pPr>
+              <a:lnSpc>
+                <a:spcPct val="150000"/>
+              </a:lnSpc>
+              <a:tabLst>
+                <a:tab algn="l" pos="1619280"/>
+              </a:tabLst>
+            </a:pPr>
+            <a:r>
+              <a:rPr b="1" sz="1400">
+                <a:solidFill>
+                  <a:srgbClr val="000000"/>
+                </a:solidFill>
+                <a:latin typeface="Nimbus Roman"/>
+              </a:rPr>
+              <a:t>Living Room	14' 4" x 14' 9"</a:t>
+            </a:r>
+          </a:p>
+          <a:p>
+            <a:pPr>
+              <a:lnSpc>
+                <a:spcPct val="150000"/>
+              </a:lnSpc>
+              <a:tabLst>
+                <a:tab algn="l" pos="1619280"/>
+              </a:tabLst>
+            </a:pPr>
+            <a:r>
+              <a:rPr b="1" sz="1400">
+                <a:solidFill>
+                  <a:srgbClr val="000000"/>
+                </a:solidFill>
+                <a:latin typeface="Nimbus Roman"/>
+              </a:rPr>
+              <a:t>Dining Room	9' 2" x 8' 9"</a:t>
+            </a:r>
+          </a:p>
+          <a:p>
+            <a:pPr>
+              <a:lnSpc>
+                <a:spcPct val="150000"/>
+              </a:lnSpc>
+              <a:tabLst>
+                <a:tab algn="l" pos="1619280"/>
+              </a:tabLst>
+            </a:pPr>
+            <a:r>
+              <a:rPr b="1" sz="1400">
+                <a:solidFill>
+                  <a:srgbClr val="000000"/>
+                </a:solidFill>
+                <a:latin typeface="Nimbus Roman"/>
+              </a:rPr>
+              <a:t>Primary Bedroom	11' 8" x 10' 6"</a:t>
+            </a:r>
+          </a:p>
+          <a:p>
+            <a:pPr>
+              <a:lnSpc>
+                <a:spcPct val="150000"/>
+              </a:lnSpc>
+              <a:tabLst>
+                <a:tab algn="l" pos="1619280"/>
+              </a:tabLst>
+            </a:pPr>
+            <a:r>
+              <a:rPr b="1" sz="1400">
+                <a:solidFill>
+                  <a:srgbClr val="000000"/>
+                </a:solidFill>
+                <a:latin typeface="Nimbus Roman"/>
+              </a:rPr>
+              <a:t>Bedroom	8' 3" x 8' 9"</a:t>
+            </a:r>
+          </a:p>
+          <a:p>
+            <a:pPr>
+              <a:lnSpc>
+                <a:spcPct val="150000"/>
+              </a:lnSpc>
+              <a:tabLst>
+                <a:tab algn="l" pos="1619280"/>
+              </a:tabLst>
+            </a:pPr>
+            <a:r>
+              <a:rPr b="1" sz="1400">
+                <a:solidFill>
+                  <a:srgbClr val="000000"/>
+                </a:solidFill>
+                <a:latin typeface="Nimbus Roman"/>
+              </a:rPr>
+              <a:t>Bathroom - Full	4 piece</a:t>
+            </a:r>
+          </a:p>
+          <a:p>
+            <a:pPr algn="ctr">
+              <a:lnSpc>
+                <a:spcPct val="150000"/>
+              </a:lnSpc>
+              <a:tabLst>
+                <a:tab algn="l" pos="1619280"/>
+              </a:tabLst>
+            </a:pPr>
+            <a:r>
+              <a:rPr b="1" sz="1400" i="1">
+                <a:solidFill>
+                  <a:srgbClr val="000000"/>
+                </a:solidFill>
+                <a:latin typeface="Nimbus Roman"/>
+              </a:rPr>
+              <a:t>Basement (674.9 sq. ft.)</a:t>
+            </a:r>
+          </a:p>
+          <a:p/>
+          <a:p>
+            <a:pPr>
+              <a:lnSpc>
+                <a:spcPct val="150000"/>
+              </a:lnSpc>
+              <a:tabLst>
+                <a:tab algn="l" pos="1619280"/>
+              </a:tabLst>
+            </a:pPr>
+            <a:r>
+              <a:rPr b="1" sz="1400">
+                <a:solidFill>
+                  <a:srgbClr val="000000"/>
+                </a:solidFill>
+                <a:latin typeface="Nimbus Roman"/>
+              </a:rPr>
+              <a:t>Bedroom	12' 7" x 12'</a:t>
+            </a:r>
+          </a:p>
+          <a:p>
+            <a:pPr>
+              <a:lnSpc>
+                <a:spcPct val="150000"/>
+              </a:lnSpc>
+              <a:tabLst>
+                <a:tab algn="l" pos="1619280"/>
+              </a:tabLst>
+            </a:pPr>
+            <a:r>
+              <a:rPr b="1" sz="1400">
+                <a:solidFill>
+                  <a:srgbClr val="000000"/>
+                </a:solidFill>
+                <a:latin typeface="Nimbus Roman"/>
+              </a:rPr>
+              <a:t>Bedroom	9' 8" x 9' 9"</a:t>
+            </a:r>
+          </a:p>
+          <a:p>
+            <a:pPr>
+              <a:lnSpc>
+                <a:spcPct val="150000"/>
+              </a:lnSpc>
+              <a:tabLst>
+                <a:tab algn="l" pos="1619280"/>
+              </a:tabLst>
+            </a:pPr>
+            <a:r>
+              <a:rPr b="1" sz="1400">
+                <a:solidFill>
+                  <a:srgbClr val="000000"/>
+                </a:solidFill>
+                <a:latin typeface="Nimbus Roman"/>
+              </a:rPr>
+              <a:t>Ensuite - Half	2 piece</a:t>
+            </a:r>
+          </a:p>
+          <a:p>
+            <a:pPr>
+              <a:lnSpc>
+                <a:spcPct val="150000"/>
+              </a:lnSpc>
+              <a:tabLst>
+                <a:tab algn="l" pos="1619280"/>
+              </a:tabLst>
+            </a:pPr>
+            <a:r>
+              <a:rPr b="1" sz="1400">
+                <a:solidFill>
+                  <a:srgbClr val="000000"/>
+                </a:solidFill>
+                <a:latin typeface="Nimbus Roman"/>
+              </a:rPr>
+              <a:t>Laundry	9' 3" x 3'</a:t>
+            </a:r>
+          </a:p>
+          <a:p>
+            <a:pPr>
+              <a:lnSpc>
+                <a:spcPct val="150000"/>
+              </a:lnSpc>
+              <a:tabLst>
+                <a:tab algn="l" pos="1619280"/>
+              </a:tabLst>
+            </a:pPr>
+            <a:r>
+              <a:rPr b="1" sz="1400">
+                <a:solidFill>
+                  <a:srgbClr val="000000"/>
+                </a:solidFill>
+                <a:latin typeface="Nimbus Roman"/>
+              </a:rPr>
+              <a:t>Family Room	19' 3" x 12' 6"</a:t>
+            </a:r>
+          </a:p>
+          <a:p>
+            <a:pPr>
+              <a:lnSpc>
+                <a:spcPct val="150000"/>
+              </a:lnSpc>
+              <a:tabLst>
+                <a:tab algn="l" pos="1619280"/>
+              </a:tabLst>
+            </a:pPr>
+            <a:r>
+              <a:rPr b="1" sz="1400">
+                <a:solidFill>
+                  <a:srgbClr val="000000"/>
+                </a:solidFill>
+                <a:latin typeface="Nimbus Roman"/>
+              </a:rPr>
+              <a:t>Storage	18' 9" x 6'</a:t>
+            </a:r>
           </a:p>
         </p:txBody>
       </p:sp>
@@ -2679,7 +2965,7 @@
       </p:pic>
       <p:pic>
         <p:nvPicPr>
-          <p:cNvPr id="44" name="Picture 43" descr="DSC03411.jpg"/>
+          <p:cNvPr id="44" name="Picture 43" descr="DSC03372.jpg"/>
           <p:cNvPicPr>
             <a:picLocks noChangeAspect="1"/>
           </p:cNvPicPr>
@@ -2729,7 +3015,7 @@
       </p:pic>
       <p:pic>
         <p:nvPicPr>
-          <p:cNvPr id="46" name="Picture 45" descr="DSC03423.jpg"/>
+          <p:cNvPr id="46" name="Picture 45" descr="DSC03428.jpg"/>
           <p:cNvPicPr>
             <a:picLocks noChangeAspect="1"/>
           </p:cNvPicPr>
@@ -2754,7 +3040,7 @@
       </p:pic>
       <p:pic>
         <p:nvPicPr>
-          <p:cNvPr id="47" name="Picture 46" descr="DSC03428.jpg"/>
+          <p:cNvPr id="47" name="Picture 46" descr="DSC03356.jpg"/>
           <p:cNvPicPr>
             <a:picLocks noChangeAspect="1"/>
           </p:cNvPicPr>

</xml_diff>